<commit_message>
Recheck Semester 1 Week 6: lecture wording fixes and notebook answer value
- 1 Lecture: slide 38 explains the "CV" term used in the pruning
  pseudo-code; grammar on slides 9 and 25; "two types" in the slide 18-19
  titles; "5/14" label on slide 18; Wikipedia link on "Wiki" (slide 15);
  book authors on slide 2
- 2 Lecture Demos: "Try it" answer quotes Outlook's gain ratio as 0.156,
  as the cell prints (0.157 on slide 30); language_info version 3.14
- 3 Tutorial: Lab.pdf unchanged

Co-Authored-By: Claude Opus 5.5 <noreply@anthropic.com>
Claude-Session: https://claude.ai/code/session_014GcpHHpV1Urav9VobnQrf9
[skip ci]
</commit_message>
<xml_diff>
--- a/content/Lectures/Semester 1/Week 6/1 Lecture/1.6 Classification Problems and Decision Tree Induction (Lecture).pptx
+++ b/content/Lectures/Semester 1/Week 6/1 Lecture/1.6 Classification Problems and Decision Tree Induction (Lecture).pptx
@@ -4178,15 +4178,17 @@
             </a:r>
             <a:r>
               <a:rPr lang="en-GB" dirty="0"/>
-              <a:t> is an extensive property of a thermodynamic system. It quantifies the number Ω of microscopic configurations (known as microstates) that are consistent with the macroscopic quantities that characterize the system (such as its volume, pressure and temperature).</a:t>
-            </a:r>
-            <a:r>
-              <a:rPr lang="en-GB" baseline="30000" dirty="0"/>
-              <a:t> Wiki </a:t>
-            </a:r>
-            <a:r>
-              <a:rPr lang="en-GB" dirty="0"/>
-              <a:t>  </a:t>
+              <a:t> is an extensive property of a thermodynamic system. It quantifies the number Ω of microscopic configurations (known as microstates) that are consistent with the macroscopic quantities that characterize the system (such as its volume, pressure and temperature). </a:t>
+            </a:r>
+            <a:r>
+              <a:rPr lang="en-GB" baseline="30000" dirty="0">
+                <a:hlinkClick r:id="rId4"/>
+              </a:rPr>
+              <a:t>Wiki</a:t>
+            </a:r>
+            <a:r>
+              <a:rPr lang="en-GB" dirty="0"/>
+              <a:t>   </a:t>
             </a:r>
           </a:p>
           <a:p>
@@ -5145,7 +5147,7 @@
           <a:p>
             <a:r>
               <a:rPr lang="en-GB" dirty="0"/>
-              <a:t>First step: 2-types of entropy computation</a:t>
+              <a:t>First step: two types of entropy computation</a:t>
             </a:r>
           </a:p>
         </p:txBody>
@@ -5306,7 +5308,7 @@
           <a:p>
             <a:r>
               <a:rPr lang="en-GB" dirty="0"/>
-              <a:t>5:14</a:t>
+              <a:t>5/14</a:t>
             </a:r>
           </a:p>
         </p:txBody>
@@ -5399,7 +5401,7 @@
           <a:p>
             <a:r>
               <a:rPr lang="en-GB" dirty="0"/>
-              <a:t>2-types of entropy computation</a:t>
+              <a:t>Two types of entropy computation</a:t>
             </a:r>
           </a:p>
         </p:txBody>
@@ -5518,7 +5520,7 @@
             </a:r>
             <a:r>
               <a:rPr lang="en-GB" dirty="0"/>
-              <a:t>. Other online resources that helped to create the slides are referenced at the end. </a:t>
+              <a:t> (Han, Kamber &amp; Pei). Other online resources that helped to create the slides are referenced at the end. </a:t>
             </a:r>
           </a:p>
           <a:p>
@@ -6319,7 +6321,7 @@
           <a:p>
             <a:r>
               <a:rPr lang="en-GB" dirty="0"/>
-              <a:t>Finalised the decision tree and it can be easily transformed to become rules </a:t>
+              <a:t>The finalised decision tree can easily be transformed into rules </a:t>
             </a:r>
           </a:p>
         </p:txBody>
@@ -10148,7 +10150,7 @@
           <a:p>
             <a:r>
               <a:rPr lang="en-GB" sz="1400" dirty="0"/>
-              <a:t>In post-pruning, we take training data and divide it into 2 parts. Hide one part of the data completely from the algorithm (the validation set) and train a full decision tree until we get leaf nodes.</a:t>
+              <a:t>In post-pruning, we take training data and divide it into 2 parts. Hide one part of the data completely from the algorithm (the validation set, called “CV” in the pseudo-code below) and train a full decision tree until we get leaf nodes.</a:t>
             </a:r>
           </a:p>
           <a:p>
@@ -12639,7 +12641,7 @@
             </a:pPr>
             <a:r>
               <a:rPr lang="en-GB" sz="2000" dirty="0"/>
-              <a:t>Decision tree induction is one of the simplest, and yet most successful forms of learning algorithm for solving classification problem.</a:t>
+              <a:t>Decision tree induction is one of the simplest, and yet most successful forms of learning algorithm for solving classification problems.</a:t>
             </a:r>
           </a:p>
           <a:p>
@@ -12649,7 +12651,7 @@
             </a:pPr>
             <a:r>
               <a:rPr lang="en-GB" sz="2000" dirty="0"/>
-              <a:t>It also serves as a good introduction to the area of inductive learning in AI domain.</a:t>
+              <a:t>It also serves as a good introduction to the area of inductive learning in the AI domain.</a:t>
             </a:r>
           </a:p>
           <a:p>

</xml_diff>